<commit_message>
Sell Restaurant/Takeaway/Events as packs, not custom projects.
Reserve configured messaging for hotel F&B and food carts so SME operators hear replace-and-go-live, not a bespoke build.

Co-authored-by: Cursor <cursoragent@cursor.com>
</commit_message>
<xml_diff>
--- a/public/sales/Hostora-Sales-Presentation.pptx
+++ b/public/sales/Hostora-Sales-Presentation.pptx
@@ -2294,7 +2294,7 @@
                 <a:ea typeface="Arial" pitchFamily="34" charset="-122"/>
                 <a:cs typeface="Arial" pitchFamily="34" charset="-120"/>
               </a:rPr>
-              <a:t>Optional local Docker server (Hostora + PostgreSQL) so tills, tablets, KDS, and printers stay on the venue network — quoted with software per venue.</a:t>
+              <a:t>Optional local Docker server (Hostora + PostgreSQL) so tills, tablets, KDS, and printers stay on the venue network — quoted with your pack.</a:t>
             </a:r>
             <a:endParaRPr lang="en-US" sz="1800" dirty="0"/>
           </a:p>
@@ -2755,7 +2755,7 @@
                 <a:ea typeface="Arial" pitchFamily="34" charset="-122"/>
                 <a:cs typeface="Arial" pitchFamily="34" charset="-120"/>
               </a:rPr>
-              <a:t>Hostora is the commercial brand for a platform already running multi-station hospitality venues. Markets: US, UK &amp; Europe. Licensing is per venue — custom quotes for multi-site, hotel F&amp;B, and food carts.</a:t>
+              <a:t>Hostora is the commercial brand for a platform already running multi-station hospitality venues. Markets: US, UK &amp; Europe. Restaurant / Takeaway / Events packs; hotel F&amp;B and food carts configured — package quote after demo.</a:t>
             </a:r>
             <a:endParaRPr lang="en-US" sz="1800" dirty="0"/>
           </a:p>
@@ -3021,7 +3021,7 @@
                 <a:ea typeface="Arial" pitchFamily="34" charset="-122"/>
                 <a:cs typeface="Arial" pitchFamily="34" charset="-120"/>
               </a:rPr>
-              <a:t>Per-venue licensing. Custom quotes for multi-site. Leave this slide open and take discovery notes.</a:t>
+              <a:t>Package quote after demo for Restaurant / Takeaway / Events. Configured quote for hotel F&amp;B and carts. Leave this slide open and take discovery notes.</a:t>
             </a:r>
             <a:endParaRPr lang="en-US" sz="1800" dirty="0"/>
           </a:p>
@@ -3809,7 +3809,7 @@
                 <a:ea typeface="Arial" pitchFamily="34" charset="-122"/>
                 <a:cs typeface="Arial" pitchFamily="34" charset="-120"/>
               </a:rPr>
-              <a:t>Packaged for restaurants, takeaways, and events. Hotel F&amp;B and food carts configured to each operator — still F&amp;B/ops, not a hotel PMS.</a:t>
+              <a:t>Restaurant / Takeaway / Events packs for fast go-live. Hotel F&amp;B and food carts configured to the outlets or footprint — still F&amp;B/ops, not a hotel PMS.</a:t>
             </a:r>
             <a:endParaRPr lang="en-US" sz="1800" dirty="0"/>
           </a:p>
@@ -3870,7 +3870,7 @@
                 <a:ea typeface="Arial" pitchFamily="34" charset="-122"/>
                 <a:cs typeface="Arial" pitchFamily="34" charset="-120"/>
               </a:rPr>
-              <a:t>Restaurants</a:t>
+              <a:t>Restaurant pack</a:t>
             </a:r>
             <a:endParaRPr lang="en-US" sz="1400" dirty="0"/>
           </a:p>
@@ -3931,7 +3931,7 @@
                 <a:ea typeface="Arial" pitchFamily="34" charset="-122"/>
                 <a:cs typeface="Arial" pitchFamily="34" charset="-120"/>
               </a:rPr>
-              <a:t>Takeaways</a:t>
+              <a:t>Takeaway pack</a:t>
             </a:r>
             <a:endParaRPr lang="en-US" sz="1400" dirty="0"/>
           </a:p>
@@ -3992,7 +3992,7 @@
                 <a:ea typeface="Arial" pitchFamily="34" charset="-122"/>
                 <a:cs typeface="Arial" pitchFamily="34" charset="-120"/>
               </a:rPr>
-              <a:t>Event venues</a:t>
+              <a:t>Events pack</a:t>
             </a:r>
             <a:endParaRPr lang="en-US" sz="1400" dirty="0"/>
           </a:p>
@@ -4053,7 +4053,7 @@
                 <a:ea typeface="Arial" pitchFamily="34" charset="-122"/>
                 <a:cs typeface="Arial" pitchFamily="34" charset="-120"/>
               </a:rPr>
-              <a:t>Hotels (F&amp;B / ops)</a:t>
+              <a:t>Hotels (F&amp;B — configured)</a:t>
             </a:r>
             <a:endParaRPr lang="en-US" sz="1400" dirty="0"/>
           </a:p>
@@ -4114,7 +4114,7 @@
                 <a:ea typeface="Arial" pitchFamily="34" charset="-122"/>
                 <a:cs typeface="Arial" pitchFamily="34" charset="-120"/>
               </a:rPr>
-              <a:t>Food carts</a:t>
+              <a:t>Food carts (configured)</a:t>
             </a:r>
             <a:endParaRPr lang="en-US" sz="1400" dirty="0"/>
           </a:p>

</xml_diff>